<commit_message>
Add the hospital demo to the pitch deck: two slides with screenshots and a live-demo script
</commit_message>
<xml_diff>
--- a/docs/pitch/SupportPilot-AI-Pitch-Deck.pptx
+++ b/docs/pitch/SupportPilot-AI-Pitch-Deck.pptx
@@ -10,7 +10,9 @@
     <p:sldId id="258" r:id="rId4"/>
     <p:sldId id="259" r:id="rId5"/>
     <p:sldId id="260" r:id="rId6"/>
+    <p:sldId id="265" r:id="rId16"/>
     <p:sldId id="261" r:id="rId7"/>
+    <p:sldId id="266" r:id="rId17"/>
     <p:sldId id="262" r:id="rId8"/>
     <p:sldId id="263" r:id="rId9"/>
     <p:sldId id="264" r:id="rId10"/>
@@ -543,6 +545,216 @@
     <p:extLst>
       <p:ext uri="{BB962C8B-B14F-4D97-AF65-F5344CB8AC3E}">
         <p14:creationId xmlns:p14="http://schemas.microsoft.com/office/powerpoint/2010/main" val="1024086991"/>
+      </p:ext>
+    </p:extLst>
+  </p:cSld>
+  <p:clrMapOvr>
+    <a:masterClrMapping/>
+  </p:clrMapOvr>
+</p:notes>
+</file>
+
+<file path=ppt/notesSlides/notesSlide10.xml><?xml version="1.0" encoding="utf-8"?>
+<p:notes xmlns:a="http://schemas.openxmlformats.org/drawingml/2006/main" xmlns:r="http://schemas.openxmlformats.org/officeDocument/2006/relationships" xmlns:p="http://schemas.openxmlformats.org/presentationml/2006/main">
+  <p:cSld>
+    <p:spTree>
+      <p:nvGrpSpPr>
+        <p:cNvPr id="1" name=""/>
+        <p:cNvGrpSpPr/>
+        <p:nvPr/>
+      </p:nvGrpSpPr>
+      <p:grpSpPr>
+        <a:xfrm>
+          <a:off x="0" y="0"/>
+          <a:ext cx="0" cy="0"/>
+          <a:chOff x="0" y="0"/>
+          <a:chExt cx="0" cy="0"/>
+        </a:xfrm>
+      </p:grpSpPr>
+      <p:sp>
+        <p:nvSpPr>
+          <p:cNvPr id="2" name="Slide Image Placeholder 1"/>
+          <p:cNvSpPr>
+            <a:spLocks noGrp="1" noRot="1" noChangeAspect="1"/>
+          </p:cNvSpPr>
+          <p:nvPr>
+            <p:ph type="sldImg"/>
+          </p:nvPr>
+        </p:nvSpPr>
+        <p:spPr/>
+      </p:sp>
+      <p:sp>
+        <p:nvSpPr>
+          <p:cNvPr id="3" name="Notes Placeholder 2"/>
+          <p:cNvSpPr>
+            <a:spLocks noGrp="1"/>
+          </p:cNvSpPr>
+          <p:nvPr>
+            <p:ph type="body" idx="1"/>
+          </p:nvPr>
+        </p:nvSpPr>
+        <p:spPr/>
+        <p:txBody>
+          <a:bodyPr/>
+          <a:lstStyle/>
+          <a:p>
+            <a:r>
+              <a:rPr lang="en-US" dirty="0"/>
+              <a:t>LIVE DEMO, about 60 seconds. Before the meeting start the app: cd backend, then LLM_PROVIDER=demo STATIC_DIR=../frontend/dist uvicorn app.main:app_factory --factory --port 8000. Open http://localhost:8000.</a:t>
+            </a:r>
+          </a:p>
+          <a:p>
+            <a:r>
+              <a:rPr lang="en-US" dirty="0"/>
+              <a:t>1) As Guest, type: How much does parking cost? The answer cites the hospital's parking document.</a:t>
+            </a:r>
+          </a:p>
+          <a:p>
+            <a:r>
+              <a:rPr lang="en-US" dirty="0"/>
+              <a:t>2) Switch to Peter and type: Where is appointment APT-1001? It shows Confirmed, Tuesday 20/10/2026 at 10:30am.</a:t>
+            </a:r>
+          </a:p>
+          <a:p>
+            <a:r>
+              <a:rPr lang="en-US" dirty="0"/>
+              <a:t>3) Type: I want to talk to a person. The chat is handed to a human; open http://localhost:8000/console/ (company wattlebay, agent sam, key wb-sam-demo-key) and reply live.</a:t>
+            </a:r>
+          </a:p>
+          <a:p>
+            <a:r>
+              <a:rPr lang="en-US" dirty="0"/>
+              <a:t>Be upfront: the demo uses a keyword stand-in model, so the wording is scripted. With a real AI model the answers read naturally. The hospital, people and policies are all fictional.</a:t>
+            </a:r>
+          </a:p>
+        </p:txBody>
+      </p:sp>
+      <p:sp>
+        <p:nvSpPr>
+          <p:cNvPr id="4" name="Slide Number Placeholder 3"/>
+          <p:cNvSpPr>
+            <a:spLocks noGrp="1"/>
+          </p:cNvSpPr>
+          <p:nvPr>
+            <p:ph type="sldNum" sz="quarter" idx="10"/>
+          </p:nvPr>
+        </p:nvSpPr>
+        <p:spPr/>
+        <p:txBody>
+          <a:bodyPr/>
+          <a:lstStyle/>
+          <a:p>
+            <a:fld id="{F7021451-1387-4CA6-816F-3879F97B5CBC}" type="slidenum">
+              <a:rPr lang="en-US"/>
+              <a:t>6</a:t>
+            </a:fld>
+            <a:endParaRPr lang="en-US"/>
+          </a:p>
+        </p:txBody>
+      </p:sp>
+    </p:spTree>
+    <p:extLst>
+      <p:ext uri="{BB962C8B-B14F-4D97-AF65-F5344CB8AC3E}">
+        <p14:creationId xmlns:p14="http://schemas.microsoft.com/office/powerpoint/2010/main" val="1024087001"/>
+      </p:ext>
+    </p:extLst>
+  </p:cSld>
+  <p:clrMapOvr>
+    <a:masterClrMapping/>
+  </p:clrMapOvr>
+</p:notes>
+</file>
+
+<file path=ppt/notesSlides/notesSlide11.xml><?xml version="1.0" encoding="utf-8"?>
+<p:notes xmlns:a="http://schemas.openxmlformats.org/drawingml/2006/main" xmlns:r="http://schemas.openxmlformats.org/officeDocument/2006/relationships" xmlns:p="http://schemas.openxmlformats.org/presentationml/2006/main">
+  <p:cSld>
+    <p:spTree>
+      <p:nvGrpSpPr>
+        <p:cNvPr id="1" name=""/>
+        <p:cNvGrpSpPr/>
+        <p:nvPr/>
+      </p:nvGrpSpPr>
+      <p:grpSpPr>
+        <a:xfrm>
+          <a:off x="0" y="0"/>
+          <a:ext cx="0" cy="0"/>
+          <a:chOff x="0" y="0"/>
+          <a:chExt cx="0" cy="0"/>
+        </a:xfrm>
+      </p:grpSpPr>
+      <p:sp>
+        <p:nvSpPr>
+          <p:cNvPr id="2" name="Slide Image Placeholder 1"/>
+          <p:cNvSpPr>
+            <a:spLocks noGrp="1" noRot="1" noChangeAspect="1"/>
+          </p:cNvSpPr>
+          <p:nvPr>
+            <p:ph type="sldImg"/>
+          </p:nvPr>
+        </p:nvSpPr>
+        <p:spPr/>
+      </p:sp>
+      <p:sp>
+        <p:nvSpPr>
+          <p:cNvPr id="3" name="Notes Placeholder 2"/>
+          <p:cNvSpPr>
+            <a:spLocks noGrp="1"/>
+          </p:cNvSpPr>
+          <p:nvPr>
+            <p:ph type="body" idx="1"/>
+          </p:nvPr>
+        </p:nvSpPr>
+        <p:spPr/>
+        <p:txBody>
+          <a:bodyPr/>
+          <a:lstStyle/>
+          <a:p>
+            <a:r>
+              <a:rPr lang="en-US" dirty="0"/>
+              <a:t>Switch to Mary and ask the same question: Where is appointment APT-1001? She is told no appointment was found, exactly as if the number did not exist, so nothing about Peter's records leaks.</a:t>
+            </a:r>
+          </a:p>
+          <a:p>
+            <a:r>
+              <a:rPr lang="en-US" dirty="0"/>
+              <a:t>Key message: the AI is never trusted with identity. Identity comes from the hospital's own signed token and is applied on the server.</a:t>
+            </a:r>
+          </a:p>
+          <a:p>
+            <a:r>
+              <a:rPr lang="en-US" dirty="0"/>
+              <a:t>If asked about medical use: this is a hospital information assistant, not a clinical tool, and real patient data would need a proper privacy and security review.</a:t>
+            </a:r>
+          </a:p>
+        </p:txBody>
+      </p:sp>
+      <p:sp>
+        <p:nvSpPr>
+          <p:cNvPr id="4" name="Slide Number Placeholder 3"/>
+          <p:cNvSpPr>
+            <a:spLocks noGrp="1"/>
+          </p:cNvSpPr>
+          <p:nvPr>
+            <p:ph type="sldNum" sz="quarter" idx="10"/>
+          </p:nvPr>
+        </p:nvSpPr>
+        <p:spPr/>
+        <p:txBody>
+          <a:bodyPr/>
+          <a:lstStyle/>
+          <a:p>
+            <a:fld id="{F7021451-1387-4CA6-816F-3879F97B5CBC}" type="slidenum">
+              <a:rPr lang="en-US"/>
+              <a:t>8</a:t>
+            </a:fld>
+            <a:endParaRPr lang="en-US"/>
+          </a:p>
+        </p:txBody>
+      </p:sp>
+    </p:spTree>
+    <p:extLst>
+      <p:ext uri="{BB962C8B-B14F-4D97-AF65-F5344CB8AC3E}">
+        <p14:creationId xmlns:p14="http://schemas.microsoft.com/office/powerpoint/2010/main" val="1024087002"/>
       </p:ext>
     </p:extLst>
   </p:cSld>
@@ -1748,6 +1960,590 @@
 </p:sld>
 </file>
 
+<file path=ppt/slides/slide10.xml><?xml version="1.0" encoding="utf-8"?>
+<p:sld xmlns:a="http://schemas.openxmlformats.org/drawingml/2006/main" xmlns:r="http://schemas.openxmlformats.org/officeDocument/2006/relationships" xmlns:p="http://schemas.openxmlformats.org/presentationml/2006/main">
+  <p:cSld name="Slide 6">
+    <p:bg>
+      <p:bgPr>
+        <a:solidFill>
+          <a:schemeClr val="bg1"/>
+        </a:solidFill>
+      </p:bgPr>
+    </p:bg>
+    <p:spTree>
+      <p:nvGrpSpPr>
+        <p:cNvPr id="1" name=""/>
+        <p:cNvGrpSpPr/>
+        <p:nvPr/>
+      </p:nvGrpSpPr>
+      <p:grpSpPr>
+        <a:xfrm>
+          <a:off x="0" y="0"/>
+          <a:ext cx="0" cy="0"/>
+          <a:chOff x="0" y="0"/>
+          <a:chExt cx="0" cy="0"/>
+        </a:xfrm>
+      </p:grpSpPr>
+      <p:sp>
+        <p:nvSpPr>
+          <p:cNvPr id="2" name="Kicker"/>
+          <p:cNvSpPr txBox="1"/>
+          <p:nvPr/>
+        </p:nvSpPr>
+        <p:spPr>
+          <a:xfrm>
+            <a:off x="548640" y="365760"/>
+            <a:ext cx="8046720" cy="274320"/>
+          </a:xfrm>
+          <a:prstGeom prst="rect">
+            <a:avLst/>
+          </a:prstGeom>
+          <a:noFill/>
+          <a:ln/>
+        </p:spPr>
+        <p:txBody>
+          <a:bodyPr wrap="square" lIns="0" tIns="0" rIns="0" bIns="0" rtlCol="0" anchor="ctr"/>
+          <a:lstStyle/>
+          <a:p>
+            <a:pPr indent="0" marL="0">
+              <a:buNone/>
+            </a:pPr>
+            <a:r>
+              <a:rPr lang="en-US" sz="1200" b="1" spc="300" kern="0" dirty="0">
+                <a:solidFill>
+                  <a:schemeClr val="accent1"/>
+                </a:solidFill>
+              </a:rPr>
+              <a:t>SEE IT IN ACTION</a:t>
+            </a:r>
+          </a:p>
+        </p:txBody>
+      </p:sp>
+      <p:sp>
+        <p:nvSpPr>
+          <p:cNvPr id="3" name="Title"/>
+          <p:cNvSpPr txBox="1"/>
+          <p:nvPr/>
+        </p:nvSpPr>
+        <p:spPr>
+          <a:xfrm>
+            <a:off x="548640" y="658368"/>
+            <a:ext cx="8046720" cy="548640"/>
+          </a:xfrm>
+          <a:prstGeom prst="rect">
+            <a:avLst/>
+          </a:prstGeom>
+          <a:noFill/>
+          <a:ln/>
+        </p:spPr>
+        <p:txBody>
+          <a:bodyPr wrap="square" lIns="0" tIns="0" rIns="0" bIns="0" rtlCol="0" anchor="t"/>
+          <a:lstStyle/>
+          <a:p>
+            <a:pPr indent="0" marL="0">
+              <a:buNone/>
+            </a:pPr>
+            <a:r>
+              <a:rPr lang="en-US" sz="3000" b="1" dirty="0">
+                <a:solidFill>
+                  <a:schemeClr val="tx1"/>
+                </a:solidFill>
+                <a:latin typeface="Cambria" pitchFamily="34" charset="0"/>
+                <a:ea typeface="Cambria" pitchFamily="34" charset="-122"/>
+                <a:cs typeface="Cambria" pitchFamily="34" charset="-120"/>
+              </a:rPr>
+              <a:t>Here it is on a Sydney hospital site</a:t>
+            </a:r>
+          </a:p>
+        </p:txBody>
+      </p:sp>
+      <p:pic>
+        <p:nvPicPr>
+          <p:cNvPr id="4" name="Hero screenshot" descr="The fictional Wattle Bay Hospital website with the chat assistant open: Peter, signed in, asks about his appointment and sees it confirmed."/>
+          <p:cNvPicPr>
+            <a:picLocks noChangeAspect="1"/>
+          </p:cNvPicPr>
+          <p:nvPr/>
+        </p:nvPicPr>
+        <p:blipFill>
+          <a:blip r:embed="rId10"/>
+          <a:stretch>
+            <a:fillRect/>
+          </a:stretch>
+        </p:blipFill>
+        <p:spPr>
+          <a:xfrm>
+            <a:off x="548640" y="1371600"/>
+            <a:ext cx="5138482" cy="3291840"/>
+          </a:xfrm>
+          <a:prstGeom prst="rect">
+            <a:avLst/>
+          </a:prstGeom>
+          <a:ln w="12700">
+            <a:solidFill>
+              <a:schemeClr val="accent5"/>
+            </a:solidFill>
+          </a:ln>
+        </p:spPr>
+      </p:pic>
+      <p:sp>
+        <p:nvSpPr>
+          <p:cNvPr id="5" name="Card"/>
+          <p:cNvSpPr/>
+          <p:nvPr/>
+        </p:nvSpPr>
+        <p:spPr>
+          <a:xfrm>
+            <a:off x="5961442" y="1371600"/>
+            <a:ext cx="2633918" cy="3291840"/>
+          </a:xfrm>
+          <a:prstGeom prst="rect">
+            <a:avLst/>
+          </a:prstGeom>
+          <a:solidFill>
+            <a:schemeClr val="bg2"/>
+          </a:solidFill>
+          <a:ln/>
+        </p:spPr>
+      </p:sp>
+      <p:sp>
+        <p:nvSpPr>
+          <p:cNvPr id="6" name="What you are seeing"/>
+          <p:cNvSpPr txBox="1"/>
+          <p:nvPr/>
+        </p:nvSpPr>
+        <p:spPr>
+          <a:xfrm>
+            <a:off x="6144322" y="1508760"/>
+            <a:ext cx="2268158" cy="3017520"/>
+          </a:xfrm>
+          <a:prstGeom prst="rect">
+            <a:avLst/>
+          </a:prstGeom>
+          <a:noFill/>
+          <a:ln/>
+        </p:spPr>
+        <p:txBody>
+          <a:bodyPr wrap="square" lIns="0" tIns="0" rIns="0" bIns="0" rtlCol="0" anchor="t"/>
+          <a:lstStyle/>
+          <a:p>
+            <a:pPr indent="0" marL="0">
+              <a:spcAft>
+                <a:spcPts val="600"/>
+              </a:spcAft>
+              <a:buNone/>
+            </a:pPr>
+            <a:r>
+              <a:rPr lang="en-US" sz="1700" b="1" dirty="0">
+                <a:solidFill>
+                  <a:schemeClr val="tx1"/>
+                </a:solidFill>
+              </a:rPr>
+              <a:t>What you are seeing</a:t>
+            </a:r>
+          </a:p>
+          <a:p>
+            <a:pPr indent="0" marL="0">
+              <a:spcAft>
+                <a:spcPts val="600"/>
+              </a:spcAft>
+              <a:buNone/>
+            </a:pPr>
+            <a:r>
+              <a:rPr lang="en-US" sz="1400" dirty="0">
+                <a:solidFill>
+                  <a:schemeClr val="accent5"/>
+                </a:solidFill>
+              </a:rPr>
+              <a:t>A fictional hospital website, built for this demo.</a:t>
+            </a:r>
+          </a:p>
+          <a:p>
+            <a:pPr indent="0" marL="0">
+              <a:spcAft>
+                <a:spcPts val="600"/>
+              </a:spcAft>
+              <a:buNone/>
+            </a:pPr>
+            <a:r>
+              <a:rPr lang="en-US" sz="1400" dirty="0">
+                <a:solidFill>
+                  <a:schemeClr val="accent5"/>
+                </a:solidFill>
+              </a:rPr>
+              <a:t>Peter is signed in. His identity comes from the hospital's own server, not from the chat.</a:t>
+            </a:r>
+          </a:p>
+          <a:p>
+            <a:pPr indent="0" marL="0">
+              <a:buNone/>
+            </a:pPr>
+            <a:r>
+              <a:rPr lang="en-US" sz="1400" dirty="0">
+                <a:solidFill>
+                  <a:schemeClr val="accent5"/>
+                </a:solidFill>
+              </a:rPr>
+              <a:t>The assistant finds his appointment, and only his.</a:t>
+            </a:r>
+          </a:p>
+        </p:txBody>
+      </p:sp>
+    </p:spTree>
+  </p:cSld>
+  <p:clrMapOvr>
+    <a:masterClrMapping/>
+  </p:clrMapOvr>
+</p:sld>
+</file>
+
+<file path=ppt/slides/slide11.xml><?xml version="1.0" encoding="utf-8"?>
+<p:sld xmlns:a="http://schemas.openxmlformats.org/drawingml/2006/main" xmlns:r="http://schemas.openxmlformats.org/officeDocument/2006/relationships" xmlns:p="http://schemas.openxmlformats.org/presentationml/2006/main">
+  <p:cSld name="Slide 8">
+    <p:bg>
+      <p:bgPr>
+        <a:solidFill>
+          <a:schemeClr val="bg1"/>
+        </a:solidFill>
+      </p:bgPr>
+    </p:bg>
+    <p:spTree>
+      <p:nvGrpSpPr>
+        <p:cNvPr id="1" name=""/>
+        <p:cNvGrpSpPr/>
+        <p:nvPr/>
+      </p:nvGrpSpPr>
+      <p:grpSpPr>
+        <a:xfrm>
+          <a:off x="0" y="0"/>
+          <a:ext cx="0" cy="0"/>
+          <a:chOff x="0" y="0"/>
+          <a:chExt cx="0" cy="0"/>
+        </a:xfrm>
+      </p:grpSpPr>
+      <p:sp>
+        <p:nvSpPr>
+          <p:cNvPr id="2" name="Kicker"/>
+          <p:cNvSpPr txBox="1"/>
+          <p:nvPr/>
+        </p:nvSpPr>
+        <p:spPr>
+          <a:xfrm>
+            <a:off x="548640" y="365760"/>
+            <a:ext cx="8046720" cy="274320"/>
+          </a:xfrm>
+          <a:prstGeom prst="rect">
+            <a:avLst/>
+          </a:prstGeom>
+          <a:noFill/>
+          <a:ln/>
+        </p:spPr>
+        <p:txBody>
+          <a:bodyPr wrap="square" lIns="0" tIns="0" rIns="0" bIns="0" rtlCol="0" anchor="ctr"/>
+          <a:lstStyle/>
+          <a:p>
+            <a:pPr indent="0" marL="0">
+              <a:buNone/>
+            </a:pPr>
+            <a:r>
+              <a:rPr lang="en-US" sz="1200" b="1" spc="300" kern="0" dirty="0">
+                <a:solidFill>
+                  <a:schemeClr val="accent1"/>
+                </a:solidFill>
+              </a:rPr>
+              <a:t>SAME QUESTION, TWO PATIENTS</a:t>
+            </a:r>
+          </a:p>
+        </p:txBody>
+      </p:sp>
+      <p:sp>
+        <p:nvSpPr>
+          <p:cNvPr id="3" name="Title"/>
+          <p:cNvSpPr txBox="1"/>
+          <p:nvPr/>
+        </p:nvSpPr>
+        <p:spPr>
+          <a:xfrm>
+            <a:off x="548640" y="658368"/>
+            <a:ext cx="8046720" cy="548640"/>
+          </a:xfrm>
+          <a:prstGeom prst="rect">
+            <a:avLst/>
+          </a:prstGeom>
+          <a:noFill/>
+          <a:ln/>
+        </p:spPr>
+        <p:txBody>
+          <a:bodyPr wrap="square" lIns="0" tIns="0" rIns="0" bIns="0" rtlCol="0" anchor="t"/>
+          <a:lstStyle/>
+          <a:p>
+            <a:pPr indent="0" marL="0">
+              <a:buNone/>
+            </a:pPr>
+            <a:r>
+              <a:rPr lang="en-US" sz="3000" b="1" dirty="0">
+                <a:solidFill>
+                  <a:schemeClr val="tx1"/>
+                </a:solidFill>
+                <a:latin typeface="Cambria" pitchFamily="34" charset="0"/>
+                <a:ea typeface="Cambria" pitchFamily="34" charset="-122"/>
+                <a:cs typeface="Cambria" pitchFamily="34" charset="-120"/>
+              </a:rPr>
+              <a:t>Mary can't see Peter's appointment</a:t>
+            </a:r>
+          </a:p>
+        </p:txBody>
+      </p:sp>
+      <p:pic>
+        <p:nvPicPr>
+          <p:cNvPr id="4" name="Peter and Mary screenshot" descr="Side by side: Peter sees his confirmed appointment, while Mary asking the same question is told no appointment was found."/>
+          <p:cNvPicPr>
+            <a:picLocks noChangeAspect="1"/>
+          </p:cNvPicPr>
+          <p:nvPr/>
+        </p:nvPicPr>
+        <p:blipFill>
+          <a:blip r:embed="rId10"/>
+          <a:stretch>
+            <a:fillRect/>
+          </a:stretch>
+        </p:blipFill>
+        <p:spPr>
+          <a:xfrm>
+            <a:off x="548640" y="1371600"/>
+            <a:ext cx="4059111" cy="3291840"/>
+          </a:xfrm>
+          <a:prstGeom prst="rect">
+            <a:avLst/>
+          </a:prstGeom>
+          <a:ln w="12700">
+            <a:solidFill>
+              <a:schemeClr val="accent5"/>
+            </a:solidFill>
+          </a:ln>
+        </p:spPr>
+      </p:pic>
+      <p:sp>
+        <p:nvSpPr>
+          <p:cNvPr id="5" name="Card"/>
+          <p:cNvSpPr/>
+          <p:nvPr/>
+        </p:nvSpPr>
+        <p:spPr>
+          <a:xfrm>
+            <a:off x="4882071" y="1371600"/>
+            <a:ext cx="3713289" cy="1033272"/>
+          </a:xfrm>
+          <a:prstGeom prst="rect">
+            <a:avLst/>
+          </a:prstGeom>
+          <a:solidFill>
+            <a:schemeClr val="bg2"/>
+          </a:solidFill>
+          <a:ln/>
+        </p:spPr>
+      </p:sp>
+      <p:sp>
+        <p:nvSpPr>
+          <p:cNvPr id="6" name="Peter, signed in"/>
+          <p:cNvSpPr txBox="1"/>
+          <p:nvPr/>
+        </p:nvSpPr>
+        <p:spPr>
+          <a:xfrm>
+            <a:off x="5064951" y="1463040"/>
+            <a:ext cx="3347529" cy="896112"/>
+          </a:xfrm>
+          <a:prstGeom prst="rect">
+            <a:avLst/>
+          </a:prstGeom>
+          <a:noFill/>
+          <a:ln/>
+        </p:spPr>
+        <p:txBody>
+          <a:bodyPr wrap="square" lIns="0" tIns="0" rIns="0" bIns="0" rtlCol="0" anchor="t"/>
+          <a:lstStyle/>
+          <a:p>
+            <a:pPr indent="0" marL="0">
+              <a:spcAft>
+                <a:spcPts val="200"/>
+              </a:spcAft>
+              <a:buNone/>
+            </a:pPr>
+            <a:r>
+              <a:rPr lang="en-US" sz="1700" b="1" dirty="0">
+                <a:solidFill>
+                  <a:schemeClr val="tx1"/>
+                </a:solidFill>
+              </a:rPr>
+              <a:t>Peter, signed in</a:t>
+            </a:r>
+          </a:p>
+          <a:p>
+            <a:pPr indent="0" marL="0">
+              <a:buNone/>
+            </a:pPr>
+            <a:r>
+              <a:rPr lang="en-US" sz="1400" dirty="0">
+                <a:solidFill>
+                  <a:schemeClr val="accent5"/>
+                </a:solidFill>
+              </a:rPr>
+              <a:t>Sees his own appointment: confirmed, Tuesday 20/10/2026 at 10:30am.</a:t>
+            </a:r>
+          </a:p>
+        </p:txBody>
+      </p:sp>
+      <p:sp>
+        <p:nvSpPr>
+          <p:cNvPr id="7" name="Card"/>
+          <p:cNvSpPr/>
+          <p:nvPr/>
+        </p:nvSpPr>
+        <p:spPr>
+          <a:xfrm>
+            <a:off x="4882071" y="2500884"/>
+            <a:ext cx="3713289" cy="1033272"/>
+          </a:xfrm>
+          <a:prstGeom prst="rect">
+            <a:avLst/>
+          </a:prstGeom>
+          <a:solidFill>
+            <a:schemeClr val="bg2"/>
+          </a:solidFill>
+          <a:ln/>
+        </p:spPr>
+      </p:sp>
+      <p:sp>
+        <p:nvSpPr>
+          <p:cNvPr id="8" name="Mary, signed in"/>
+          <p:cNvSpPr txBox="1"/>
+          <p:nvPr/>
+        </p:nvSpPr>
+        <p:spPr>
+          <a:xfrm>
+            <a:off x="5064951" y="2592324"/>
+            <a:ext cx="3347529" cy="896112"/>
+          </a:xfrm>
+          <a:prstGeom prst="rect">
+            <a:avLst/>
+          </a:prstGeom>
+          <a:noFill/>
+          <a:ln/>
+        </p:spPr>
+        <p:txBody>
+          <a:bodyPr wrap="square" lIns="0" tIns="0" rIns="0" bIns="0" rtlCol="0" anchor="t"/>
+          <a:lstStyle/>
+          <a:p>
+            <a:pPr indent="0" marL="0">
+              <a:spcAft>
+                <a:spcPts val="200"/>
+              </a:spcAft>
+              <a:buNone/>
+            </a:pPr>
+            <a:r>
+              <a:rPr lang="en-US" sz="1700" b="1" dirty="0">
+                <a:solidFill>
+                  <a:schemeClr val="tx1"/>
+                </a:solidFill>
+              </a:rPr>
+              <a:t>Mary, signed in</a:t>
+            </a:r>
+          </a:p>
+          <a:p>
+            <a:pPr indent="0" marL="0">
+              <a:buNone/>
+            </a:pPr>
+            <a:r>
+              <a:rPr lang="en-US" sz="1400" dirty="0">
+                <a:solidFill>
+                  <a:schemeClr val="accent5"/>
+                </a:solidFill>
+              </a:rPr>
+              <a:t>Told no appointment was found. The reply is identical to a number that does not exist.</a:t>
+            </a:r>
+          </a:p>
+        </p:txBody>
+      </p:sp>
+      <p:sp>
+        <p:nvSpPr>
+          <p:cNvPr id="9" name="Card"/>
+          <p:cNvSpPr/>
+          <p:nvPr/>
+        </p:nvSpPr>
+        <p:spPr>
+          <a:xfrm>
+            <a:off x="4882071" y="3630168"/>
+            <a:ext cx="3713289" cy="1033272"/>
+          </a:xfrm>
+          <a:prstGeom prst="rect">
+            <a:avLst/>
+          </a:prstGeom>
+          <a:solidFill>
+            <a:schemeClr val="bg2"/>
+          </a:solidFill>
+          <a:ln/>
+        </p:spPr>
+      </p:sp>
+      <p:sp>
+        <p:nvSpPr>
+          <p:cNvPr id="10" name="Why it is safe"/>
+          <p:cNvSpPr txBox="1"/>
+          <p:nvPr/>
+        </p:nvSpPr>
+        <p:spPr>
+          <a:xfrm>
+            <a:off x="5064951" y="3721608"/>
+            <a:ext cx="3347529" cy="896112"/>
+          </a:xfrm>
+          <a:prstGeom prst="rect">
+            <a:avLst/>
+          </a:prstGeom>
+          <a:noFill/>
+          <a:ln/>
+        </p:spPr>
+        <p:txBody>
+          <a:bodyPr wrap="square" lIns="0" tIns="0" rIns="0" bIns="0" rtlCol="0" anchor="t"/>
+          <a:lstStyle/>
+          <a:p>
+            <a:pPr indent="0" marL="0">
+              <a:spcAft>
+                <a:spcPts val="200"/>
+              </a:spcAft>
+              <a:buNone/>
+            </a:pPr>
+            <a:r>
+              <a:rPr lang="en-US" sz="1700" b="1" dirty="0">
+                <a:solidFill>
+                  <a:schemeClr val="tx1"/>
+                </a:solidFill>
+              </a:rPr>
+              <a:t>Why it is safe</a:t>
+            </a:r>
+          </a:p>
+          <a:p>
+            <a:pPr indent="0" marL="0">
+              <a:buNone/>
+            </a:pPr>
+            <a:r>
+              <a:rPr lang="en-US" sz="1400" dirty="0">
+                <a:solidFill>
+                  <a:schemeClr val="accent5"/>
+                </a:solidFill>
+              </a:rPr>
+              <a:t>The hospital's server signs who is asking. The AI never chooses whose records to read.</a:t>
+            </a:r>
+          </a:p>
+        </p:txBody>
+      </p:sp>
+    </p:spTree>
+  </p:cSld>
+  <p:clrMapOvr>
+    <a:masterClrMapping/>
+  </p:clrMapOvr>
+</p:sld>
+</file>
+
 <file path=ppt/slides/slide2.xml><?xml version="1.0" encoding="utf-8"?>
 <p:sld xmlns:a="http://schemas.openxmlformats.org/drawingml/2006/main" xmlns:r="http://schemas.openxmlformats.org/officeDocument/2006/relationships" xmlns:p="http://schemas.openxmlformats.org/presentationml/2006/main">
   <p:cSld name="Slide 2">
@@ -6197,7 +6993,7 @@
                 <a:ea typeface="Cambria" pitchFamily="34" charset="-122"/>
                 <a:cs typeface="Cambria" pitchFamily="34" charset="-120"/>
               </a:rPr>
-              <a:t>Service businesses</a:t>
+              <a:t>Healthcare and services</a:t>
             </a:r>
             <a:endParaRPr lang="en-US" sz="1700" dirty="0"/>
           </a:p>
@@ -6233,7 +7029,7 @@
                   <a:schemeClr val="accent5"/>
                 </a:solidFill>
               </a:rPr>
-              <a:t>Hours, bookings, pricing, FAQs</a:t>
+              <a:t>Visiting hours, appointments, parking, FAQs</a:t>
             </a:r>
             <a:endParaRPr lang="en-US" sz="1400" dirty="0"/>
           </a:p>

</xml_diff>